<commit_message>
P6 quality passes, and the texture measurements recorded
schedule.ts is deleted with its test; its two constants live in scheduler.ts.
Review of 5eafd76, d36a7a4 and 5a9d406: one helper for the two identical
diagnose calls, a plan with no solver bound is labelled heuristic only when
it is the heuristic's, small tidies. A rupee figure on the array panel no
longer breaks across lines. README, backlog and the status box brought in
line. The three supplied textures were scored and flown, not wired in.

Co-Authored-By: Claude Opus 5.5 <noreply@anthropic.com>
</commit_message>
<xml_diff>
--- a/ppt/SURYA-AGENT-Round1.pptx
+++ b/ppt/SURYA-AGENT-Round1.pptx
@@ -121,53 +121,53 @@
   <p:extLst>
     <p:ext uri="{521415D9-36F7-43E2-AB2F-B90AF26B5E84}">
       <p14:sectionLst xmlns:p14="http://schemas.microsoft.com/office/powerpoint/2010/main">
-        <p14:section name="Opening" id="{edf32ef1-c689-c78d-fb04-3002e5d03233}">
+        <p14:section name="Opening" id="{3ca58df0-116f-d320-3db1-ec179532eed9}">
           <p14:sldIdLst>
             <p14:sldId id="256"/>
           </p14:sldIdLst>
         </p14:section>
-        <p14:section name="1 Problem" id="{f1b5cc30-cf3d-be8c-0e52-4819715dd2f8}">
+        <p14:section name="1 Problem" id="{3385b83f-35f0-063f-c01b-8ef1810823cc}">
           <p14:sldIdLst>
             <p14:sldId id="257"/>
           </p14:sldIdLst>
         </p14:section>
-        <p14:section name="2 Gaps" id="{25f0b62c-e2f9-0542-b1c4-e762e88effe4}">
+        <p14:section name="2 Gaps" id="{063d85a5-f5b6-d7df-14db-6ee4acbb8cd7}">
           <p14:sldIdLst>
             <p14:sldId id="258"/>
           </p14:sldIdLst>
         </p14:section>
-        <p14:section name="3 Solution" id="{8996dd77-ffe4-8249-fd02-4b9cde201f3f}">
+        <p14:section name="3 Solution" id="{4eac6ca0-da95-7543-7d27-b3f80f5b198b}">
           <p14:sldIdLst>
             <p14:sldId id="259"/>
             <p14:sldId id="260"/>
             <p14:sldId id="261"/>
           </p14:sldIdLst>
         </p14:section>
-        <p14:section name="4 Innovation" id="{1a6a16e3-7ac3-6152-979d-35c5cc133073}">
+        <p14:section name="4 Innovation" id="{4eec429c-e0eb-6307-5fe6-32c234004dc7}">
           <p14:sldIdLst>
             <p14:sldId id="262"/>
             <p14:sldId id="263"/>
             <p14:sldId id="264"/>
           </p14:sldIdLst>
         </p14:section>
-        <p14:section name="5 Impact" id="{4a49b9b1-ef29-5997-5ea0-a32561b9858c}">
+        <p14:section name="5 Impact" id="{e8e1ff4e-9dd2-574b-28dc-0e85f35a2771}">
           <p14:sldIdLst>
             <p14:sldId id="265"/>
           </p14:sldIdLst>
         </p14:section>
-        <p14:section name="6 Prototype" id="{7e687d26-f32a-c2ae-28b9-b836c52c788b}">
+        <p14:section name="6 Prototype" id="{597b1dc9-d57c-9106-4293-a088163aa9b8}">
           <p14:sldIdLst>
             <p14:sldId id="266"/>
             <p14:sldId id="267"/>
             <p14:sldId id="268"/>
           </p14:sldIdLst>
         </p14:section>
-        <p14:section name="7 Future" id="{6a97f725-7644-7875-86fb-2f91e64dcd81}">
+        <p14:section name="7 Future" id="{bfda0046-abcf-af49-d363-8ee60e87ead9}">
           <p14:sldIdLst>
             <p14:sldId id="269"/>
           </p14:sldIdLst>
         </p14:section>
-        <p14:section name="Declarations" id="{164a0e96-0271-d2b8-7157-3ad6f3c8aff9}">
+        <p14:section name="Declarations" id="{55983d26-16a3-3d2c-3e99-df30be67030f}">
           <p14:sldIdLst>
             <p14:sldId id="270"/>
           </p14:sldIdLst>

</xml_diff>